<commit_message>
ppt: replace 7B scoreboard with FLOPs-normalized 3-chart comparison
Slides 9-11 now show FLOPs-normalized 7B variant comparison:
  Slide 9: FLOPs-PPL curves — 8 variants, x-axis = cumulative FLOPs (PFLOPs)
  Slide 10: FLOPs scoreboard — final PPL + PFLOPs per variant
  Slide 11 (new): PPL/TFLOP efficiency ranking

FLOPs accounting per cycle (Qwen2.5-7B, ~7.6B params):
  ALS = 4 x 7.6B = 30.5 GFLOPs
  50 SGD = 50 x 6 x 7.6B = 2,280 GFLOPs
  Eval = 3 x 7.6B = 22.8 GFLOPs
  Total per cycle = 2.34 TFLOPs

Key result: CONSTANT 48c achieves PPL 7.6 at 0.112 PFLOPs,
but No-Perturb 8c is most efficient at 569 PPL/TFLOP
</commit_message>
<xml_diff>
--- a/docs/weekly_group_meeting_20260724.pptx
+++ b/docs/weekly_group_meeting_20260724.pptx
@@ -15,6 +15,7 @@
     <p:sldId id="263" r:id="rId14"/>
     <p:sldId id="264" r:id="rId15"/>
     <p:sldId id="265" r:id="rId16"/>
+    <p:sldId id="278" r:id="rId29"/>
     <p:sldId id="266" r:id="rId17"/>
     <p:sldId id="267" r:id="rId18"/>
     <p:sldId id="268" r:id="rId19"/>
@@ -13784,6 +13785,112 @@
           </a:p>
         </p:txBody>
       </p:sp>
+    </p:spTree>
+  </p:cSld>
+  <p:clrMapOvr>
+    <a:masterClrMapping/>
+  </p:clrMapOvr>
+</p:sld>
+</file>
+
+<file path=ppt/slides/slide23.xml><?xml version="1.0" encoding="utf-8"?>
+<p:sld xmlns:a="http://schemas.openxmlformats.org/drawingml/2006/main" xmlns:p="http://schemas.openxmlformats.org/presentationml/2006/main" xmlns:r="http://schemas.openxmlformats.org/officeDocument/2006/relationships">
+  <p:cSld>
+    <p:spTree>
+      <p:nvGrpSpPr>
+        <p:cNvPr id="1" name=""/>
+        <p:cNvGrpSpPr/>
+        <p:nvPr/>
+      </p:nvGrpSpPr>
+      <p:grpSpPr/>
+      <p:sp>
+        <p:nvSpPr>
+          <p:cNvPr id="2" name="Rectangle 1"/>
+          <p:cNvSpPr/>
+          <p:nvPr/>
+        </p:nvSpPr>
+        <p:spPr>
+          <a:xfrm>
+            <a:off x="0" y="0"/>
+            <a:ext cx="12191695" cy="960120"/>
+          </a:xfrm>
+          <a:prstGeom prst="rect">
+            <a:avLst/>
+          </a:prstGeom>
+          <a:solidFill>
+            <a:srgbClr val="1F497D"/>
+          </a:solidFill>
+          <a:ln>
+            <a:noFill/>
+          </a:ln>
+        </p:spPr>
+        <p:style>
+          <a:lnRef idx="1">
+            <a:schemeClr val="accent1"/>
+          </a:lnRef>
+          <a:fillRef idx="3">
+            <a:schemeClr val="accent1"/>
+          </a:fillRef>
+          <a:effectRef idx="2">
+            <a:schemeClr val="accent1"/>
+          </a:effectRef>
+          <a:fontRef idx="minor">
+            <a:schemeClr val="lt1"/>
+          </a:fontRef>
+        </p:style>
+        <p:txBody>
+          <a:bodyPr rtlCol="0" anchor="ctr" wrap="square" lIns="548640" tIns="137160"/>
+          <a:lstStyle/>
+          <a:p>
+            <a:pPr algn="ctr">
+              <a:defRPr sz="2600" b="1">
+                <a:solidFill>
+                  <a:srgbClr val="FFFFFF"/>
+                </a:solidFill>
+              </a:defRPr>
+            </a:pPr>
+            <a:r>
+              <a:t>7B FLOPs Efficiency: PPL per TFLOP</a:t>
+            </a:r>
+          </a:p>
+          <a:p>
+            <a:pPr>
+              <a:defRPr sz="1300" i="1">
+                <a:solidFill>
+                  <a:srgbClr val="CCDDEE"/>
+                </a:solidFill>
+              </a:defRPr>
+            </a:pPr>
+            <a:r>
+              <a:t>Qwen2.5-7B (28L) — PPL improvement per unit of compute (lower = better)</a:t>
+            </a:r>
+          </a:p>
+        </p:txBody>
+      </p:sp>
+      <p:pic>
+        <p:nvPicPr>
+          <p:cNvPr id="3" name="Picture 2" descr="weekly_7b_efficiency.png"/>
+          <p:cNvPicPr>
+            <a:picLocks noChangeAspect="1"/>
+          </p:cNvPicPr>
+          <p:nvPr/>
+        </p:nvPicPr>
+        <p:blipFill>
+          <a:blip r:embed="rId2"/>
+          <a:stretch>
+            <a:fillRect/>
+          </a:stretch>
+        </p:blipFill>
+        <p:spPr>
+          <a:xfrm>
+            <a:off x="182880" y="1051560"/>
+            <a:ext cx="11795760" cy="5577840"/>
+          </a:xfrm>
+          <a:prstGeom prst="rect">
+            <a:avLst/>
+          </a:prstGeom>
+        </p:spPr>
+      </p:pic>
     </p:spTree>
   </p:cSld>
   <p:clrMapOvr>

</xml_diff>